<commit_message>
Reframe RDD manipulation slide; 60d outcome window; add Q15/Q16
</commit_message>
<xml_diff>
--- a/deck/vanguard_dda_deck.pptx
+++ b/deck/vanguard_dda_deck.pptx
@@ -1839,7 +1839,7 @@
           <a:p>
             <a:r>
               <a:rPr lang="en-US" dirty="0"/>
-              <a:t>This check matters because RDD's validity hinges entirely on people not being able to precisely manipulate which side of the cutoff they land on. I run this BEFORE trusting any effect estimate.</a:t>
+              <a:t>If asked 'why check this at all, customers don't know the 30% rule exists' — that's exactly right, and it's why I don't expect INTENTIONAL gaming. But the McCrary test isn't only a test for intentional gaming; it's a general smoothness check on the running variable's density, which would also catch unrelated sources of bunching (e.g. round-number withdrawal amounts, or some other bank rule that happens to also trigger near 30%) that could bias the comparison even without anyone trying to dodge OUR rule specifically. It's also the standard, expected validation step for any RDD -- skipping it is what would actually raise questions, and it's specifically what lets this method carry a 'high confidence, directly tested' label instead of DoubleML's 'moderate confidence, untestable assumption' label a few slides later.</a:t>
             </a:r>
             <a:endParaRPr lang="en-US" dirty="0"/>
           </a:p>
@@ -10838,7 +10838,7 @@
                 <a:ea typeface="Cambria" pitchFamily="34" charset="-122"/>
                 <a:cs typeface="Cambria" pitchFamily="34" charset="-120"/>
               </a:rPr>
-              <a:t>The identifying assumption: no one can “game” the 30% line</a:t>
+              <a:t>The identifying assumption: the running variable isn't manipulated</a:t>
             </a:r>
             <a:endParaRPr lang="en-US" sz="2800" dirty="0"/>
           </a:p>
@@ -10955,7 +10955,7 @@
         <p:spPr>
           <a:xfrm>
             <a:off x="7223760" y="2514600"/>
-            <a:ext cx="4389120" cy="1188720"/>
+            <a:ext cx="4389120" cy="1371600"/>
           </a:xfrm>
           <a:prstGeom prst="rect">
             <a:avLst/>
@@ -10969,7 +10969,7 @@
           <a:p>
             <a:pPr indent="0" marL="0">
               <a:lnSpc>
-                <a:spcPct val="125000"/>
+                <a:spcPct val="120000"/>
               </a:lnSpc>
               <a:buNone/>
             </a:pPr>
@@ -10982,7 +10982,7 @@
                 <a:ea typeface="Calibri" pitchFamily="34" charset="-122"/>
                 <a:cs typeface="Calibri" pitchFamily="34" charset="-120"/>
               </a:rPr>
-              <a:t>If customers could nudge a withdrawal just above/below 30% to trigger or dodge an RM call, the density of the running variable would jump at the cutoff — and RDD would be invalid.</a:t>
+              <a:t>Customers don't know this internal 30% threshold exists, so deliberate dodging isn't the realistic risk — the real risk is any OTHER unknown reason withdrawal size might bunch near 30% (round-number withdrawal habits, an unrelated internal rule). This test checks for that directly instead of just asserting it away.</a:t>
             </a:r>
             <a:endParaRPr lang="en-US" sz="1200" dirty="0"/>
           </a:p>
@@ -10996,7 +10996,7 @@
         </p:nvSpPr>
         <p:spPr>
           <a:xfrm>
-            <a:off x="7223760" y="3840480"/>
+            <a:off x="7223760" y="4069080"/>
             <a:ext cx="4389120" cy="914400"/>
           </a:xfrm>
           <a:prstGeom prst="roundRect">
@@ -11025,7 +11025,7 @@
         </p:nvSpPr>
         <p:spPr>
           <a:xfrm>
-            <a:off x="7333488" y="3950208"/>
+            <a:off x="7333488" y="4178808"/>
             <a:ext cx="4169664" cy="502920"/>
           </a:xfrm>
           <a:prstGeom prst="rect">
@@ -11064,7 +11064,7 @@
         </p:nvSpPr>
         <p:spPr>
           <a:xfrm>
-            <a:off x="7333488" y="4389120"/>
+            <a:off x="7333488" y="4617720"/>
             <a:ext cx="4169664" cy="347472"/>
           </a:xfrm>
           <a:prstGeom prst="rect">
@@ -11103,8 +11103,8 @@
         </p:nvSpPr>
         <p:spPr>
           <a:xfrm>
-            <a:off x="7223760" y="4892040"/>
-            <a:ext cx="4389120" cy="1188720"/>
+            <a:off x="7223760" y="5120640"/>
+            <a:ext cx="4389120" cy="914400"/>
           </a:xfrm>
           <a:prstGeom prst="rect">
             <a:avLst/>
@@ -11131,7 +11131,7 @@
                 <a:ea typeface="Calibri" pitchFamily="34" charset="-122"/>
                 <a:cs typeface="Calibri" pitchFamily="34" charset="-120"/>
               </a:rPr>
-              <a:t>No evidence of manipulation — withdrawal size is a real economic behavior, not something dialed in to dodge a phone call.</a:t>
+              <a:t>No jump in the density at 30% — consistent with a smooth, unmanipulated running variable.</a:t>
             </a:r>
             <a:endParaRPr lang="en-US" sz="1200" dirty="0"/>
           </a:p>
@@ -11241,7 +11241,7 @@
                 <a:ea typeface="Cambria" pitchFamily="34" charset="-122"/>
                 <a:cs typeface="Cambria" pitchFamily="34" charset="-120"/>
               </a:rPr>
-              <a:t>RM outreach cuts next-month churn by ~11 points at the margin</a:t>
+              <a:t>RM outreach cuts 60-day churn by ~11 points at the margin</a:t>
             </a:r>
             <a:endParaRPr lang="en-US" sz="2800" dirty="0"/>
           </a:p>

</xml_diff>

<commit_message>
Slide 5: frame elevated synthetic churn rate vs real 0.8% baseline
</commit_message>
<xml_diff>
--- a/deck/vanguard_dda_deck.pptx
+++ b/deck/vanguard_dda_deck.pptx
@@ -1841,7 +1841,7 @@
           <a:p>
             <a:r>
               <a:rPr lang="en-US" dirty="0"/>
-              <a:t>Engagement, DD stability, and liquidity-need scores dominate, as expected -- and region importance sits at noise level, a good sanity check that the model isn't picking up spurious geography effects. I evaluate by ranking quality, not hard-classification accuracy, because forcing balanced weights on an 89%-none target produces garbage precision numbers that don't reflect how the model is actually used. This layer's job is purely routing: WHICH causal-layer estimate applies to this account.</a:t>
+              <a:t>Engagement, DD stability, and liquidity-need scores dominate, as expected -- and region importance sits at noise level, a good sanity check that the model isn't picking up spurious geography effects. I evaluate by ranking quality, not hard-classification accuracy, because forcing balanced weights on an 89%-none target produces garbage precision numbers that don't reflect how the model is actually used. This layer's job is purely routing: WHICH causal-layer estimate applies to this account. One honest note if asked: the real project's actual observed baseline churn was about 0.8% over a 2-month A/B window -- this synthetic demo's panel intentionally runs hotter, around 11% combined across modes, because with a few thousand HV/LV accounts I need enough injected churn events per mode for the RDD/DiD/RCT layers to actually have statistical power to detect anything. At a true 0.8% base rate on this account count, most of those designs would come back underpowered and I'd have nothing clean to show. So the elevated rate is a deliberate demo-scale choice, not a claim about what real DDA churn looks like -- and I say that up front rather than waiting to be asked.</a:t>
             </a:r>
             <a:endParaRPr lang="en-US" dirty="0"/>
           </a:p>
@@ -12657,7 +12657,7 @@
                 <a:ea typeface="Calibri" pitchFamily="34" charset="-122"/>
                 <a:cs typeface="Calibri" pitchFamily="34" charset="-120"/>
               </a:rPr>
-              <a:t>Churn is rare (~11% combined across modes) and driven by noisy human behavior — this isn't a 0.95-AUC problem. In production you rank and act on the top slice your capacity allows, not hard-classify at a single threshold, exactly like the causal layer's HV/LV split on the next slides.</a:t>
+              <a:t>Churn is rare (~11% combined across modes) — deliberately elevated above the real project's ~0.8% observed baseline so this compact synthetic panel still has enough events per mode to power RDD/DiD/RCT cleanly. Not a 0.95-AUC problem; in production you rank and act on the top slice your capacity allows, not hard-classify at a threshold.</a:t>
             </a:r>
             <a:endParaRPr lang="en-US" sz="1250" dirty="0"/>
           </a:p>

</xml_diff>